<commit_message>
Update database structure 2
</commit_message>
<xml_diff>
--- a/models/contracts/contracts.pptx
+++ b/models/contracts/contracts.pptx
@@ -12768,7 +12768,7 @@
           <a:p>
             <a:fld id="{8745A381-7B0D-FA47-B45A-5742BCADC568}" type="datetimeFigureOut">
               <a:rPr lang="en-US" smtClean="0"/>
-              <a:t>3/4/26</a:t>
+              <a:t>3/6/26</a:t>
             </a:fld>
             <a:endParaRPr lang="en-US"/>
           </a:p>
@@ -13166,7 +13166,7 @@
           <a:p>
             <a:fld id="{1BCC6876-C5F6-C848-9706-E462062BCA22}" type="datetimeFigureOut">
               <a:rPr lang="en-US" smtClean="0"/>
-              <a:t>3/4/26</a:t>
+              <a:t>3/6/26</a:t>
             </a:fld>
             <a:endParaRPr lang="en-US" dirty="0"/>
           </a:p>
@@ -13336,7 +13336,7 @@
           <a:p>
             <a:fld id="{1BCC6876-C5F6-C848-9706-E462062BCA22}" type="datetimeFigureOut">
               <a:rPr lang="en-US" smtClean="0"/>
-              <a:t>3/4/26</a:t>
+              <a:t>3/6/26</a:t>
             </a:fld>
             <a:endParaRPr lang="en-US" dirty="0"/>
           </a:p>
@@ -13516,7 +13516,7 @@
           <a:p>
             <a:fld id="{1BCC6876-C5F6-C848-9706-E462062BCA22}" type="datetimeFigureOut">
               <a:rPr lang="en-US" smtClean="0"/>
-              <a:t>3/4/26</a:t>
+              <a:t>3/6/26</a:t>
             </a:fld>
             <a:endParaRPr lang="en-US" dirty="0"/>
           </a:p>
@@ -13686,7 +13686,7 @@
           <a:p>
             <a:fld id="{1BCC6876-C5F6-C848-9706-E462062BCA22}" type="datetimeFigureOut">
               <a:rPr lang="en-US" smtClean="0"/>
-              <a:t>3/4/26</a:t>
+              <a:t>3/6/26</a:t>
             </a:fld>
             <a:endParaRPr lang="en-US" dirty="0"/>
           </a:p>
@@ -13932,7 +13932,7 @@
           <a:p>
             <a:fld id="{1BCC6876-C5F6-C848-9706-E462062BCA22}" type="datetimeFigureOut">
               <a:rPr lang="en-US" smtClean="0"/>
-              <a:t>3/4/26</a:t>
+              <a:t>3/6/26</a:t>
             </a:fld>
             <a:endParaRPr lang="en-US" dirty="0"/>
           </a:p>
@@ -14164,7 +14164,7 @@
           <a:p>
             <a:fld id="{1BCC6876-C5F6-C848-9706-E462062BCA22}" type="datetimeFigureOut">
               <a:rPr lang="en-US" smtClean="0"/>
-              <a:t>3/4/26</a:t>
+              <a:t>3/6/26</a:t>
             </a:fld>
             <a:endParaRPr lang="en-US" dirty="0"/>
           </a:p>
@@ -14531,7 +14531,7 @@
           <a:p>
             <a:fld id="{1BCC6876-C5F6-C848-9706-E462062BCA22}" type="datetimeFigureOut">
               <a:rPr lang="en-US" smtClean="0"/>
-              <a:t>3/4/26</a:t>
+              <a:t>3/6/26</a:t>
             </a:fld>
             <a:endParaRPr lang="en-US" dirty="0"/>
           </a:p>
@@ -14649,7 +14649,7 @@
           <a:p>
             <a:fld id="{1BCC6876-C5F6-C848-9706-E462062BCA22}" type="datetimeFigureOut">
               <a:rPr lang="en-US" smtClean="0"/>
-              <a:t>3/4/26</a:t>
+              <a:t>3/6/26</a:t>
             </a:fld>
             <a:endParaRPr lang="en-US" dirty="0"/>
           </a:p>
@@ -14744,7 +14744,7 @@
           <a:p>
             <a:fld id="{1BCC6876-C5F6-C848-9706-E462062BCA22}" type="datetimeFigureOut">
               <a:rPr lang="en-US" smtClean="0"/>
-              <a:t>3/4/26</a:t>
+              <a:t>3/6/26</a:t>
             </a:fld>
             <a:endParaRPr lang="en-US" dirty="0"/>
           </a:p>
@@ -15021,7 +15021,7 @@
           <a:p>
             <a:fld id="{1BCC6876-C5F6-C848-9706-E462062BCA22}" type="datetimeFigureOut">
               <a:rPr lang="en-US" smtClean="0"/>
-              <a:t>3/4/26</a:t>
+              <a:t>3/6/26</a:t>
             </a:fld>
             <a:endParaRPr lang="en-US" dirty="0"/>
           </a:p>
@@ -15277,7 +15277,7 @@
           <a:p>
             <a:fld id="{1BCC6876-C5F6-C848-9706-E462062BCA22}" type="datetimeFigureOut">
               <a:rPr lang="en-US" smtClean="0"/>
-              <a:t>3/4/26</a:t>
+              <a:t>3/6/26</a:t>
             </a:fld>
             <a:endParaRPr lang="en-US" dirty="0"/>
           </a:p>
@@ -15496,7 +15496,7 @@
           <a:p>
             <a:fld id="{1BCC6876-C5F6-C848-9706-E462062BCA22}" type="datetimeFigureOut">
               <a:rPr lang="en-US" smtClean="0"/>
-              <a:t>3/4/26</a:t>
+              <a:t>3/6/26</a:t>
             </a:fld>
             <a:endParaRPr lang="en-US" dirty="0"/>
           </a:p>
@@ -15935,7 +15935,7 @@
                 <a:ea typeface="Cambria Math" panose="02040503050406030204" pitchFamily="18" charset="0"/>
                 <a:cs typeface="Tahoma" panose="020B0604030504040204" pitchFamily="34" charset="0"/>
               </a:rPr>
-              <a:t>Can we accurately predict NHL free agents’ contracts?</a:t>
+              <a:t>Can we accurately predict free agent skaters’ contracts?</a:t>
             </a:r>
           </a:p>
         </p:txBody>

</xml_diff>